<commit_message>
update to first lesso
</commit_message>
<xml_diff>
--- a/How to use Python.pptx
+++ b/How to use Python.pptx
@@ -282,7 +282,7 @@
           <a:p>
             <a:fld id="{783CD771-E527-0B44-BA3C-FA5AD0F40365}" type="datetimeFigureOut">
               <a:rPr lang="en-US" smtClean="0"/>
-              <a:t>1/12/26</a:t>
+              <a:t>8/24/26</a:t>
             </a:fld>
             <a:endParaRPr lang="en-US"/>
           </a:p>
@@ -480,7 +480,7 @@
           <a:p>
             <a:fld id="{783CD771-E527-0B44-BA3C-FA5AD0F40365}" type="datetimeFigureOut">
               <a:rPr lang="en-US" smtClean="0"/>
-              <a:t>1/12/26</a:t>
+              <a:t>8/24/26</a:t>
             </a:fld>
             <a:endParaRPr lang="en-US"/>
           </a:p>
@@ -688,7 +688,7 @@
           <a:p>
             <a:fld id="{783CD771-E527-0B44-BA3C-FA5AD0F40365}" type="datetimeFigureOut">
               <a:rPr lang="en-US" smtClean="0"/>
-              <a:t>1/12/26</a:t>
+              <a:t>8/24/26</a:t>
             </a:fld>
             <a:endParaRPr lang="en-US"/>
           </a:p>
@@ -886,7 +886,7 @@
           <a:p>
             <a:fld id="{783CD771-E527-0B44-BA3C-FA5AD0F40365}" type="datetimeFigureOut">
               <a:rPr lang="en-US" smtClean="0"/>
-              <a:t>1/12/26</a:t>
+              <a:t>8/24/26</a:t>
             </a:fld>
             <a:endParaRPr lang="en-US"/>
           </a:p>
@@ -1161,7 +1161,7 @@
           <a:p>
             <a:fld id="{783CD771-E527-0B44-BA3C-FA5AD0F40365}" type="datetimeFigureOut">
               <a:rPr lang="en-US" smtClean="0"/>
-              <a:t>1/12/26</a:t>
+              <a:t>8/24/26</a:t>
             </a:fld>
             <a:endParaRPr lang="en-US"/>
           </a:p>
@@ -1426,7 +1426,7 @@
           <a:p>
             <a:fld id="{783CD771-E527-0B44-BA3C-FA5AD0F40365}" type="datetimeFigureOut">
               <a:rPr lang="en-US" smtClean="0"/>
-              <a:t>1/12/26</a:t>
+              <a:t>8/24/26</a:t>
             </a:fld>
             <a:endParaRPr lang="en-US"/>
           </a:p>
@@ -1838,7 +1838,7 @@
           <a:p>
             <a:fld id="{783CD771-E527-0B44-BA3C-FA5AD0F40365}" type="datetimeFigureOut">
               <a:rPr lang="en-US" smtClean="0"/>
-              <a:t>1/12/26</a:t>
+              <a:t>8/24/26</a:t>
             </a:fld>
             <a:endParaRPr lang="en-US"/>
           </a:p>
@@ -1979,7 +1979,7 @@
           <a:p>
             <a:fld id="{783CD771-E527-0B44-BA3C-FA5AD0F40365}" type="datetimeFigureOut">
               <a:rPr lang="en-US" smtClean="0"/>
-              <a:t>1/12/26</a:t>
+              <a:t>8/24/26</a:t>
             </a:fld>
             <a:endParaRPr lang="en-US"/>
           </a:p>
@@ -2092,7 +2092,7 @@
           <a:p>
             <a:fld id="{783CD771-E527-0B44-BA3C-FA5AD0F40365}" type="datetimeFigureOut">
               <a:rPr lang="en-US" smtClean="0"/>
-              <a:t>1/12/26</a:t>
+              <a:t>8/24/26</a:t>
             </a:fld>
             <a:endParaRPr lang="en-US"/>
           </a:p>
@@ -2403,7 +2403,7 @@
           <a:p>
             <a:fld id="{783CD771-E527-0B44-BA3C-FA5AD0F40365}" type="datetimeFigureOut">
               <a:rPr lang="en-US" smtClean="0"/>
-              <a:t>1/12/26</a:t>
+              <a:t>8/24/26</a:t>
             </a:fld>
             <a:endParaRPr lang="en-US"/>
           </a:p>
@@ -2691,7 +2691,7 @@
           <a:p>
             <a:fld id="{783CD771-E527-0B44-BA3C-FA5AD0F40365}" type="datetimeFigureOut">
               <a:rPr lang="en-US" smtClean="0"/>
-              <a:t>1/12/26</a:t>
+              <a:t>8/24/26</a:t>
             </a:fld>
             <a:endParaRPr lang="en-US"/>
           </a:p>
@@ -2932,7 +2932,7 @@
           <a:p>
             <a:fld id="{783CD771-E527-0B44-BA3C-FA5AD0F40365}" type="datetimeFigureOut">
               <a:rPr lang="en-US" smtClean="0"/>
-              <a:t>1/12/26</a:t>
+              <a:t>8/24/26</a:t>
             </a:fld>
             <a:endParaRPr lang="en-US"/>
           </a:p>
@@ -3351,85 +3351,23 @@
       </p:grpSpPr>
       <p:sp>
         <p:nvSpPr>
-          <p:cNvPr id="2" name="Title 1">
-            <a:extLst>
-              <a:ext uri="{FF2B5EF4-FFF2-40B4-BE49-F238E27FC236}">
-                <a16:creationId xmlns:a16="http://schemas.microsoft.com/office/drawing/2014/main" id="{C3D74C35-48BB-223B-B13E-5D12E1A6C5B4}"/>
-              </a:ext>
-            </a:extLst>
-          </p:cNvPr>
-          <p:cNvSpPr>
-            <a:spLocks noGrp="1"/>
-          </p:cNvSpPr>
-          <p:nvPr>
-            <p:ph type="ctrTitle"/>
+          <p:cNvPr id="3" name="Subtitle 2">
+            <a:extLst>
+              <a:ext uri="{FF2B5EF4-FFF2-40B4-BE49-F238E27FC236}">
+                <a16:creationId xmlns:a16="http://schemas.microsoft.com/office/drawing/2014/main" id="{256BD58E-7C44-C62F-7C44-F73719BC7350}"/>
+              </a:ext>
+            </a:extLst>
+          </p:cNvPr>
+          <p:cNvSpPr>
+            <a:spLocks noGrp="1"/>
+          </p:cNvSpPr>
+          <p:nvPr>
+            <p:ph type="subTitle" idx="1"/>
           </p:nvPr>
         </p:nvSpPr>
         <p:spPr>
           <a:xfrm>
-            <a:off x="1550504" y="1603918"/>
-            <a:ext cx="9144000" cy="1877511"/>
-          </a:xfrm>
-        </p:spPr>
-        <p:txBody>
-          <a:bodyPr>
-            <a:normAutofit fontScale="90000"/>
-          </a:bodyPr>
-          <a:lstStyle/>
-          <a:p>
-            <a:br>
-              <a:rPr lang="en-US" dirty="0">
-                <a:effectLst/>
-                <a:latin typeface="Calibri" panose="020F0502020204030204" pitchFamily="34" charset="0"/>
-              </a:rPr>
-            </a:br>
-            <a:r>
-              <a:rPr lang="en-US" dirty="0">
-                <a:effectLst/>
-                <a:latin typeface="Calibri" panose="020F0502020204030204" pitchFamily="34" charset="0"/>
-              </a:rPr>
-              <a:t>APK 4720 / APK 6725</a:t>
-            </a:r>
-            <a:br>
-              <a:rPr lang="en-US" dirty="0">
-                <a:effectLst/>
-                <a:latin typeface="Calibri" panose="020F0502020204030204" pitchFamily="34" charset="0"/>
-              </a:rPr>
-            </a:br>
-            <a:r>
-              <a:rPr lang="en-US" dirty="0">
-                <a:effectLst/>
-                <a:latin typeface="Calibri" panose="020F0502020204030204" pitchFamily="34" charset="0"/>
-              </a:rPr>
-              <a:t>AI for Movement Sciences</a:t>
-            </a:r>
-            <a:endParaRPr lang="en-US" dirty="0">
-              <a:solidFill>
-                <a:schemeClr val="tx1"/>
-              </a:solidFill>
-            </a:endParaRPr>
-          </a:p>
-        </p:txBody>
-      </p:sp>
-      <p:sp>
-        <p:nvSpPr>
-          <p:cNvPr id="3" name="Subtitle 2">
-            <a:extLst>
-              <a:ext uri="{FF2B5EF4-FFF2-40B4-BE49-F238E27FC236}">
-                <a16:creationId xmlns:a16="http://schemas.microsoft.com/office/drawing/2014/main" id="{256BD58E-7C44-C62F-7C44-F73719BC7350}"/>
-              </a:ext>
-            </a:extLst>
-          </p:cNvPr>
-          <p:cNvSpPr>
-            <a:spLocks noGrp="1"/>
-          </p:cNvSpPr>
-          <p:nvPr>
-            <p:ph type="subTitle" idx="1"/>
-          </p:nvPr>
-        </p:nvSpPr>
-        <p:spPr>
-          <a:xfrm>
-            <a:off x="1751997" y="3858126"/>
+            <a:off x="1817199" y="4558399"/>
             <a:ext cx="8779376" cy="1351722"/>
           </a:xfrm>
         </p:spPr>
@@ -3440,7 +3378,7 @@
           <a:lstStyle/>
           <a:p>
             <a:r>
-              <a:rPr lang="en-US" dirty="0"/>
+              <a:rPr lang="en-US" sz="3200" dirty="0"/>
               <a:t>Introduction to Python</a:t>
             </a:r>
           </a:p>
@@ -3641,6 +3579,68 @@
           <a:p>
             <a:pPr algn="ctr"/>
             <a:endParaRPr lang="en-US" dirty="0"/>
+          </a:p>
+        </p:txBody>
+      </p:sp>
+      <p:sp>
+        <p:nvSpPr>
+          <p:cNvPr id="10" name="Title 1">
+            <a:extLst>
+              <a:ext uri="{FF2B5EF4-FFF2-40B4-BE49-F238E27FC236}">
+                <a16:creationId xmlns:a16="http://schemas.microsoft.com/office/drawing/2014/main" id="{DED9B5D4-5959-8D97-EE58-E2BA568A2DA2}"/>
+              </a:ext>
+            </a:extLst>
+          </p:cNvPr>
+          <p:cNvSpPr>
+            <a:spLocks noGrp="1"/>
+          </p:cNvSpPr>
+          <p:nvPr>
+            <p:ph type="ctrTitle"/>
+          </p:nvPr>
+        </p:nvSpPr>
+        <p:spPr>
+          <a:xfrm>
+            <a:off x="791086" y="2490244"/>
+            <a:ext cx="10701195" cy="1877511"/>
+          </a:xfrm>
+        </p:spPr>
+        <p:txBody>
+          <a:bodyPr>
+            <a:normAutofit fontScale="90000"/>
+          </a:bodyPr>
+          <a:lstStyle/>
+          <a:p>
+            <a:br>
+              <a:rPr lang="en-US" dirty="0">
+                <a:effectLst/>
+                <a:latin typeface="Calibri" panose="020F0502020204030204" pitchFamily="34" charset="0"/>
+              </a:rPr>
+            </a:br>
+            <a:r>
+              <a:rPr lang="en-US" u="sng" dirty="0">
+                <a:effectLst/>
+                <a:latin typeface="Calibri" panose="020F0502020204030204" pitchFamily="34" charset="0"/>
+              </a:rPr>
+              <a:t>APK 6725</a:t>
+            </a:r>
+            <a:br>
+              <a:rPr lang="en-US" dirty="0">
+                <a:effectLst/>
+                <a:latin typeface="Calibri" panose="020F0502020204030204" pitchFamily="34" charset="0"/>
+              </a:rPr>
+            </a:br>
+            <a:r>
+              <a:rPr lang="en-US" dirty="0">
+                <a:effectLst/>
+                <a:latin typeface="Calibri" panose="020F0502020204030204" pitchFamily="34" charset="0"/>
+              </a:rPr>
+              <a:t>AI for Sports and  Movement Sciences</a:t>
+            </a:r>
+            <a:endParaRPr lang="en-US" dirty="0">
+              <a:solidFill>
+                <a:schemeClr val="tx1"/>
+              </a:solidFill>
+            </a:endParaRPr>
           </a:p>
         </p:txBody>
       </p:sp>
@@ -5627,7 +5627,7 @@
               <a:rPr lang="en-US" b="0" i="0" dirty="0">
                 <a:effectLst/>
               </a:rPr>
-              <a:t>You should be able to complete all this course using Google </a:t>
+              <a:t>We will use Google </a:t>
             </a:r>
             <a:r>
               <a:rPr lang="en-US" b="0" i="0" dirty="0" err="1">
@@ -5639,7 +5639,7 @@
               <a:rPr lang="en-US" b="0" i="0" dirty="0">
                 <a:effectLst/>
               </a:rPr>
-              <a:t>.</a:t>
+              <a:t> in the class, you should be able to complete all the class activities within this environment. </a:t>
             </a:r>
             <a:endParaRPr lang="en-US" dirty="0"/>
           </a:p>
@@ -6336,7 +6336,9 @@
         </p:nvSpPr>
         <p:spPr/>
         <p:txBody>
-          <a:bodyPr/>
+          <a:bodyPr>
+            <a:normAutofit lnSpcReduction="10000"/>
+          </a:bodyPr>
           <a:lstStyle/>
           <a:p>
             <a:pPr marL="0" indent="0">
@@ -6359,7 +6361,16 @@
             </a:pPr>
             <a:r>
               <a:rPr lang="en-US" dirty="0"/>
-              <a:t>The easiest (in my opinion) way to install Python is via anaconda. To get started, visit </a:t>
+              <a:t>The easiest (in my opinion) way to install Python is via anaconda. </a:t>
+            </a:r>
+          </a:p>
+          <a:p>
+            <a:pPr marL="0" indent="0">
+              <a:buNone/>
+            </a:pPr>
+            <a:r>
+              <a:rPr lang="en-US" dirty="0"/>
+              <a:t>To get started, visit </a:t>
             </a:r>
           </a:p>
           <a:p>

</xml_diff>